<commit_message>
Redo the team slide around the founder's record
Four terse cells undersold it. The slide now leads with the founder's
own line, lists what was shipped before Rialto with the two Circle
product integrations -- USDC/CCTP in proofflow, Developer Controlled
Wallets in economic-immune-system -- picked out, because for this
reviewer that is the credential, and puts Rialto's nine days as
figures on the right: six verified contracts, 71 tests, 259 days of
ECB data, an oracle failure mode taken from 37.8% to 3.2%, an invoice
and a forward settled, a 4:34 video. Both the printed PDF and the
editable .pptx carry the same slide; the .pptx still validates.

Co-Authored-By: Claude Fable 5.1 <noreply@anthropic.com>
Claude-Session: https://claude.ai/code/session_01TjcBqoaPkY77GTrYLhW488
</commit_message>
<xml_diff>
--- a/deck/rialto-deck.pptx
+++ b/deck/rialto-deck.pptx
@@ -4187,7 +4187,7 @@
         </p:nvSpPr>
         <p:spPr>
           <a:xfrm>
-            <a:off x="640080" y="640080"/>
+            <a:off x="640080" y="502920"/>
             <a:ext cx="7863840" cy="274320"/>
           </a:xfrm>
           <a:prstGeom prst="rect">
@@ -4226,8 +4226,8 @@
         </p:nvSpPr>
         <p:spPr>
           <a:xfrm>
-            <a:off x="640080" y="1234440"/>
-            <a:ext cx="7863840" cy="1828800"/>
+            <a:off x="640080" y="868680"/>
+            <a:ext cx="7863840" cy="914400"/>
           </a:xfrm>
           <a:prstGeom prst="rect">
             <a:avLst/>
@@ -4243,7 +4243,7 @@
               <a:buNone/>
             </a:pPr>
             <a:r>
-              <a:rPr lang="en-US" sz="4000" b="1" dirty="0">
+              <a:rPr lang="en-US" sz="2700" b="1" dirty="0">
                 <a:solidFill>
                   <a:srgbClr val="FFFFFF"/>
                 </a:solidFill>
@@ -4251,16 +4251,16 @@
                 <a:ea typeface="Arial" pitchFamily="34" charset="-122"/>
                 <a:cs typeface="Arial" pitchFamily="34" charset="-120"/>
               </a:rPr>
-              <a:t>I build systems a stranger</a:t>
-            </a:r>
-            <a:endParaRPr lang="en-US" sz="4000" dirty="0"/>
-          </a:p>
-          <a:p>
-            <a:pPr indent="0" marL="0">
-              <a:buNone/>
-            </a:pPr>
-            <a:r>
-              <a:rPr lang="en-US" sz="4000" b="1" dirty="0">
+              <a:t>I build systems a stranger can re-derive.</a:t>
+            </a:r>
+            <a:endParaRPr lang="en-US" sz="2700" dirty="0"/>
+          </a:p>
+          <a:p>
+            <a:pPr indent="0" marL="0">
+              <a:buNone/>
+            </a:pPr>
+            <a:r>
+              <a:rPr lang="en-US" sz="2700" b="1" dirty="0">
                 <a:solidFill>
                   <a:srgbClr val="FFFFFF"/>
                 </a:solidFill>
@@ -4268,9 +4268,9 @@
                 <a:ea typeface="Arial" pitchFamily="34" charset="-122"/>
                 <a:cs typeface="Arial" pitchFamily="34" charset="-120"/>
               </a:rPr>
-              <a:t>can re-derive. Then I attack them.</a:t>
-            </a:r>
-            <a:endParaRPr lang="en-US" sz="4000" dirty="0"/>
+              <a:t>Then I attack them.</a:t>
+            </a:r>
+            <a:endParaRPr lang="en-US" sz="2700" dirty="0"/>
           </a:p>
         </p:txBody>
       </p:sp>
@@ -4282,8 +4282,8 @@
         </p:nvSpPr>
         <p:spPr>
           <a:xfrm>
-            <a:off x="640080" y="2788920"/>
-            <a:ext cx="3840480" cy="384048"/>
+            <a:off x="640080" y="1874520"/>
+            <a:ext cx="4572000" cy="228600"/>
           </a:xfrm>
           <a:prstGeom prst="rect">
             <a:avLst/>
@@ -4299,7 +4299,514 @@
               <a:buNone/>
             </a:pPr>
             <a:r>
-              <a:rPr lang="en-US" sz="1700" b="1" dirty="0">
+              <a:rPr lang="en-US" sz="950" b="1" spc="300" kern="0" dirty="0">
+                <a:solidFill>
+                  <a:srgbClr val="6B6A64"/>
+                </a:solidFill>
+                <a:latin typeface="Calibri" pitchFamily="34" charset="0"/>
+                <a:ea typeface="Calibri" pitchFamily="34" charset="-122"/>
+                <a:cs typeface="Calibri" pitchFamily="34" charset="-120"/>
+              </a:rPr>
+              <a:t>SHIPPED BEFORE RIALTO</a:t>
+            </a:r>
+            <a:endParaRPr lang="en-US" sz="950" dirty="0"/>
+          </a:p>
+        </p:txBody>
+      </p:sp>
+      <p:sp>
+        <p:nvSpPr>
+          <p:cNvPr id="5" name="Text 3"/>
+          <p:cNvSpPr txBox="1"/>
+          <p:nvPr/>
+        </p:nvSpPr>
+        <p:spPr>
+          <a:xfrm>
+            <a:off x="640080" y="2148840"/>
+            <a:ext cx="1325880" cy="438912"/>
+          </a:xfrm>
+          <a:prstGeom prst="rect">
+            <a:avLst/>
+          </a:prstGeom>
+          <a:noFill/>
+          <a:ln/>
+        </p:spPr>
+        <p:txBody>
+          <a:bodyPr wrap="square" lIns="0" tIns="0" rIns="0" bIns="0" rtlCol="0" anchor="t"/>
+          <a:lstStyle/>
+          <a:p>
+            <a:pPr indent="0" marL="0">
+              <a:buNone/>
+            </a:pPr>
+            <a:r>
+              <a:rPr lang="en-US" sz="1050" b="1" dirty="0">
+                <a:solidFill>
+                  <a:srgbClr val="FFFFFF"/>
+                </a:solidFill>
+                <a:latin typeface="Calibri" pitchFamily="34" charset="0"/>
+                <a:ea typeface="Calibri" pitchFamily="34" charset="-122"/>
+                <a:cs typeface="Calibri" pitchFamily="34" charset="-120"/>
+              </a:rPr>
+              <a:t>Germline</a:t>
+            </a:r>
+            <a:endParaRPr lang="en-US" sz="1050" dirty="0"/>
+          </a:p>
+        </p:txBody>
+      </p:sp>
+      <p:sp>
+        <p:nvSpPr>
+          <p:cNvPr id="6" name="Text 4"/>
+          <p:cNvSpPr txBox="1"/>
+          <p:nvPr/>
+        </p:nvSpPr>
+        <p:spPr>
+          <a:xfrm>
+            <a:off x="2011680" y="2148840"/>
+            <a:ext cx="3200400" cy="438912"/>
+          </a:xfrm>
+          <a:prstGeom prst="rect">
+            <a:avLst/>
+          </a:prstGeom>
+          <a:noFill/>
+          <a:ln/>
+        </p:spPr>
+        <p:txBody>
+          <a:bodyPr wrap="square" lIns="0" tIns="0" rIns="0" bIns="0" rtlCol="0" anchor="t"/>
+          <a:lstStyle/>
+          <a:p>
+            <a:pPr indent="0" marL="0">
+              <a:buNone/>
+            </a:pPr>
+            <a:r>
+              <a:rPr lang="en-US" sz="950" dirty="0">
+                <a:solidFill>
+                  <a:srgbClr val="C3C2B7"/>
+                </a:solidFill>
+                <a:latin typeface="Calibri" pitchFamily="34" charset="0"/>
+                <a:ea typeface="Calibri" pitchFamily="34" charset="-122"/>
+                <a:cs typeface="Calibri" pitchFamily="34" charset="-120"/>
+              </a:rPr>
+              <a:t>Verifiable AI-configuration tuning, live on 0G mainnet; every step recorded on-chain.</a:t>
+            </a:r>
+            <a:endParaRPr lang="en-US" sz="950" dirty="0"/>
+          </a:p>
+        </p:txBody>
+      </p:sp>
+      <p:sp>
+        <p:nvSpPr>
+          <p:cNvPr id="7" name="Text 5"/>
+          <p:cNvSpPr txBox="1"/>
+          <p:nvPr/>
+        </p:nvSpPr>
+        <p:spPr>
+          <a:xfrm>
+            <a:off x="640080" y="2606040"/>
+            <a:ext cx="1325880" cy="438912"/>
+          </a:xfrm>
+          <a:prstGeom prst="rect">
+            <a:avLst/>
+          </a:prstGeom>
+          <a:noFill/>
+          <a:ln/>
+        </p:spPr>
+        <p:txBody>
+          <a:bodyPr wrap="square" lIns="0" tIns="0" rIns="0" bIns="0" rtlCol="0" anchor="t"/>
+          <a:lstStyle/>
+          <a:p>
+            <a:pPr indent="0" marL="0">
+              <a:buNone/>
+            </a:pPr>
+            <a:r>
+              <a:rPr lang="en-US" sz="1050" b="1" dirty="0">
+                <a:solidFill>
+                  <a:srgbClr val="FFFFFF"/>
+                </a:solidFill>
+                <a:latin typeface="Calibri" pitchFamily="34" charset="0"/>
+                <a:ea typeface="Calibri" pitchFamily="34" charset="-122"/>
+                <a:cs typeface="Calibri" pitchFamily="34" charset="-120"/>
+              </a:rPr>
+              <a:t>BIP 360 conformance</a:t>
+            </a:r>
+            <a:endParaRPr lang="en-US" sz="1050" dirty="0"/>
+          </a:p>
+        </p:txBody>
+      </p:sp>
+      <p:sp>
+        <p:nvSpPr>
+          <p:cNvPr id="8" name="Text 6"/>
+          <p:cNvSpPr txBox="1"/>
+          <p:nvPr/>
+        </p:nvSpPr>
+        <p:spPr>
+          <a:xfrm>
+            <a:off x="2011680" y="2606040"/>
+            <a:ext cx="3200400" cy="438912"/>
+          </a:xfrm>
+          <a:prstGeom prst="rect">
+            <a:avLst/>
+          </a:prstGeom>
+          <a:noFill/>
+          <a:ln/>
+        </p:spPr>
+        <p:txBody>
+          <a:bodyPr wrap="square" lIns="0" tIns="0" rIns="0" bIns="0" rtlCol="0" anchor="t"/>
+          <a:lstStyle/>
+          <a:p>
+            <a:pPr indent="0" marL="0">
+              <a:buNone/>
+            </a:pPr>
+            <a:r>
+              <a:rPr lang="en-US" sz="950" dirty="0">
+                <a:solidFill>
+                  <a:srgbClr val="C3C2B7"/>
+                </a:solidFill>
+                <a:latin typeface="Calibri" pitchFamily="34" charset="0"/>
+                <a:ea typeface="Calibri" pitchFamily="34" charset="-122"/>
+                <a:cs typeface="Calibri" pitchFamily="34" charset="-120"/>
+              </a:rPr>
+              <a:t>From-scratch implementation vs the official reference, 13 vectors and 2,000 random trees: two real gaps found in the reference.</a:t>
+            </a:r>
+            <a:endParaRPr lang="en-US" sz="950" dirty="0"/>
+          </a:p>
+        </p:txBody>
+      </p:sp>
+      <p:sp>
+        <p:nvSpPr>
+          <p:cNvPr id="9" name="Text 7"/>
+          <p:cNvSpPr txBox="1"/>
+          <p:nvPr/>
+        </p:nvSpPr>
+        <p:spPr>
+          <a:xfrm>
+            <a:off x="640080" y="3063240"/>
+            <a:ext cx="1325880" cy="438912"/>
+          </a:xfrm>
+          <a:prstGeom prst="rect">
+            <a:avLst/>
+          </a:prstGeom>
+          <a:noFill/>
+          <a:ln/>
+        </p:spPr>
+        <p:txBody>
+          <a:bodyPr wrap="square" lIns="0" tIns="0" rIns="0" bIns="0" rtlCol="0" anchor="t"/>
+          <a:lstStyle/>
+          <a:p>
+            <a:pPr indent="0" marL="0">
+              <a:buNone/>
+            </a:pPr>
+            <a:r>
+              <a:rPr lang="en-US" sz="1050" b="1" dirty="0">
+                <a:solidFill>
+                  <a:srgbClr val="FFFFFF"/>
+                </a:solidFill>
+                <a:latin typeface="Calibri" pitchFamily="34" charset="0"/>
+                <a:ea typeface="Calibri" pitchFamily="34" charset="-122"/>
+                <a:cs typeface="Calibri" pitchFamily="34" charset="-120"/>
+              </a:rPr>
+              <a:t>rein</a:t>
+            </a:r>
+            <a:endParaRPr lang="en-US" sz="1050" dirty="0"/>
+          </a:p>
+        </p:txBody>
+      </p:sp>
+      <p:sp>
+        <p:nvSpPr>
+          <p:cNvPr id="10" name="Text 8"/>
+          <p:cNvSpPr txBox="1"/>
+          <p:nvPr/>
+        </p:nvSpPr>
+        <p:spPr>
+          <a:xfrm>
+            <a:off x="2011680" y="3063240"/>
+            <a:ext cx="3200400" cy="438912"/>
+          </a:xfrm>
+          <a:prstGeom prst="rect">
+            <a:avLst/>
+          </a:prstGeom>
+          <a:noFill/>
+          <a:ln/>
+        </p:spPr>
+        <p:txBody>
+          <a:bodyPr wrap="square" lIns="0" tIns="0" rIns="0" bIns="0" rtlCol="0" anchor="t"/>
+          <a:lstStyle/>
+          <a:p>
+            <a:pPr indent="0" marL="0">
+              <a:buNone/>
+            </a:pPr>
+            <a:r>
+              <a:rPr lang="en-US" sz="950" dirty="0">
+                <a:solidFill>
+                  <a:srgbClr val="C3C2B7"/>
+                </a:solidFill>
+                <a:latin typeface="Calibri" pitchFamily="34" charset="0"/>
+                <a:ea typeface="Calibri" pitchFamily="34" charset="-122"/>
+                <a:cs typeface="Calibri" pitchFamily="34" charset="-120"/>
+              </a:rPr>
+              <a:t>A smart account an agent can operate and cannot drain. Verified source; six attacks lost nothing. 46 tests.</a:t>
+            </a:r>
+            <a:endParaRPr lang="en-US" sz="950" dirty="0"/>
+          </a:p>
+        </p:txBody>
+      </p:sp>
+      <p:sp>
+        <p:nvSpPr>
+          <p:cNvPr id="11" name="Text 9"/>
+          <p:cNvSpPr txBox="1"/>
+          <p:nvPr/>
+        </p:nvSpPr>
+        <p:spPr>
+          <a:xfrm>
+            <a:off x="640080" y="3520440"/>
+            <a:ext cx="1325880" cy="438912"/>
+          </a:xfrm>
+          <a:prstGeom prst="rect">
+            <a:avLst/>
+          </a:prstGeom>
+          <a:noFill/>
+          <a:ln/>
+        </p:spPr>
+        <p:txBody>
+          <a:bodyPr wrap="square" lIns="0" tIns="0" rIns="0" bIns="0" rtlCol="0" anchor="t"/>
+          <a:lstStyle/>
+          <a:p>
+            <a:pPr indent="0" marL="0">
+              <a:buNone/>
+            </a:pPr>
+            <a:r>
+              <a:rPr lang="en-US" sz="1050" b="1" dirty="0">
+                <a:solidFill>
+                  <a:srgbClr val="FFB38A"/>
+                </a:solidFill>
+                <a:latin typeface="Calibri" pitchFamily="34" charset="0"/>
+                <a:ea typeface="Calibri" pitchFamily="34" charset="-122"/>
+                <a:cs typeface="Calibri" pitchFamily="34" charset="-120"/>
+              </a:rPr>
+              <a:t>proofflow</a:t>
+            </a:r>
+            <a:endParaRPr lang="en-US" sz="1050" dirty="0"/>
+          </a:p>
+        </p:txBody>
+      </p:sp>
+      <p:sp>
+        <p:nvSpPr>
+          <p:cNvPr id="12" name="Text 10"/>
+          <p:cNvSpPr txBox="1"/>
+          <p:nvPr/>
+        </p:nvSpPr>
+        <p:spPr>
+          <a:xfrm>
+            <a:off x="2011680" y="3520440"/>
+            <a:ext cx="3200400" cy="438912"/>
+          </a:xfrm>
+          <a:prstGeom prst="rect">
+            <a:avLst/>
+          </a:prstGeom>
+          <a:noFill/>
+          <a:ln/>
+        </p:spPr>
+        <p:txBody>
+          <a:bodyPr wrap="square" lIns="0" tIns="0" rIns="0" bIns="0" rtlCol="0" anchor="t"/>
+          <a:lstStyle/>
+          <a:p>
+            <a:pPr indent="0" marL="0">
+              <a:buNone/>
+            </a:pPr>
+            <a:r>
+              <a:rPr lang="en-US" sz="950" dirty="0">
+                <a:solidFill>
+                  <a:srgbClr val="C3C2B7"/>
+                </a:solidFill>
+                <a:latin typeface="Calibri" pitchFamily="34" charset="0"/>
+                <a:ea typeface="Calibri" pitchFamily="34" charset="-122"/>
+                <a:cs typeface="Calibri" pitchFamily="34" charset="-120"/>
+              </a:rPr>
+              <a:t>Revenue-based credit for emerging-market SMBs on Solana, built on USDC and CCTP, Arcium MPC. Live.</a:t>
+            </a:r>
+            <a:endParaRPr lang="en-US" sz="950" dirty="0"/>
+          </a:p>
+        </p:txBody>
+      </p:sp>
+      <p:sp>
+        <p:nvSpPr>
+          <p:cNvPr id="13" name="Text 11"/>
+          <p:cNvSpPr txBox="1"/>
+          <p:nvPr/>
+        </p:nvSpPr>
+        <p:spPr>
+          <a:xfrm>
+            <a:off x="640080" y="3977640"/>
+            <a:ext cx="1325880" cy="438912"/>
+          </a:xfrm>
+          <a:prstGeom prst="rect">
+            <a:avLst/>
+          </a:prstGeom>
+          <a:noFill/>
+          <a:ln/>
+        </p:spPr>
+        <p:txBody>
+          <a:bodyPr wrap="square" lIns="0" tIns="0" rIns="0" bIns="0" rtlCol="0" anchor="t"/>
+          <a:lstStyle/>
+          <a:p>
+            <a:pPr indent="0" marL="0">
+              <a:buNone/>
+            </a:pPr>
+            <a:r>
+              <a:rPr lang="en-US" sz="1050" b="1" dirty="0">
+                <a:solidFill>
+                  <a:srgbClr val="FFB38A"/>
+                </a:solidFill>
+                <a:latin typeface="Calibri" pitchFamily="34" charset="0"/>
+                <a:ea typeface="Calibri" pitchFamily="34" charset="-122"/>
+                <a:cs typeface="Calibri" pitchFamily="34" charset="-120"/>
+              </a:rPr>
+              <a:t>economic-immune-system</a:t>
+            </a:r>
+            <a:endParaRPr lang="en-US" sz="1050" dirty="0"/>
+          </a:p>
+        </p:txBody>
+      </p:sp>
+      <p:sp>
+        <p:nvSpPr>
+          <p:cNvPr id="14" name="Text 12"/>
+          <p:cNvSpPr txBox="1"/>
+          <p:nvPr/>
+        </p:nvSpPr>
+        <p:spPr>
+          <a:xfrm>
+            <a:off x="2011680" y="3977640"/>
+            <a:ext cx="3200400" cy="438912"/>
+          </a:xfrm>
+          <a:prstGeom prst="rect">
+            <a:avLst/>
+          </a:prstGeom>
+          <a:noFill/>
+          <a:ln/>
+        </p:spPr>
+        <p:txBody>
+          <a:bodyPr wrap="square" lIns="0" tIns="0" rIns="0" bIns="0" rtlCol="0" anchor="t"/>
+          <a:lstStyle/>
+          <a:p>
+            <a:pPr indent="0" marL="0">
+              <a:buNone/>
+            </a:pPr>
+            <a:r>
+              <a:rPr lang="en-US" sz="950" dirty="0">
+                <a:solidFill>
+                  <a:srgbClr val="C3C2B7"/>
+                </a:solidFill>
+                <a:latin typeface="Calibri" pitchFamily="34" charset="0"/>
+                <a:ea typeface="Calibri" pitchFamily="34" charset="-122"/>
+                <a:cs typeface="Calibri" pitchFamily="34" charset="-120"/>
+              </a:rPr>
+              <a:t>Transaction authorisation against a budget policy, built on Circle Developer Controlled Wallets.</a:t>
+            </a:r>
+            <a:endParaRPr lang="en-US" sz="950" dirty="0"/>
+          </a:p>
+        </p:txBody>
+      </p:sp>
+      <p:sp>
+        <p:nvSpPr>
+          <p:cNvPr id="15" name="Text 13"/>
+          <p:cNvSpPr txBox="1"/>
+          <p:nvPr/>
+        </p:nvSpPr>
+        <p:spPr>
+          <a:xfrm>
+            <a:off x="640080" y="4434840"/>
+            <a:ext cx="4572000" cy="365760"/>
+          </a:xfrm>
+          <a:prstGeom prst="rect">
+            <a:avLst/>
+          </a:prstGeom>
+          <a:noFill/>
+          <a:ln/>
+        </p:spPr>
+        <p:txBody>
+          <a:bodyPr wrap="square" lIns="0" tIns="0" rIns="0" bIns="0" rtlCol="0" anchor="t"/>
+          <a:lstStyle/>
+          <a:p>
+            <a:pPr indent="0" marL="0">
+              <a:buNone/>
+            </a:pPr>
+            <a:r>
+              <a:rPr lang="en-US" sz="900" i="1" dirty="0">
+                <a:solidFill>
+                  <a:srgbClr val="8D8B82"/>
+                </a:solidFill>
+                <a:latin typeface="Calibri" pitchFamily="34" charset="0"/>
+                <a:ea typeface="Calibri" pitchFamily="34" charset="-122"/>
+                <a:cs typeface="Calibri" pitchFamily="34" charset="-120"/>
+              </a:rPr>
+              <a:t>So CCTP and Circle Wallets, marked planned in the milestones, are products I have already shipped with. What is new is Arc, and the primitive Arc is missing.</a:t>
+            </a:r>
+            <a:endParaRPr lang="en-US" sz="900" dirty="0"/>
+          </a:p>
+        </p:txBody>
+      </p:sp>
+      <p:sp>
+        <p:nvSpPr>
+          <p:cNvPr id="16" name="Text 14"/>
+          <p:cNvSpPr txBox="1"/>
+          <p:nvPr/>
+        </p:nvSpPr>
+        <p:spPr>
+          <a:xfrm>
+            <a:off x="5577840" y="1874520"/>
+            <a:ext cx="2926080" cy="228600"/>
+          </a:xfrm>
+          <a:prstGeom prst="rect">
+            <a:avLst/>
+          </a:prstGeom>
+          <a:noFill/>
+          <a:ln/>
+        </p:spPr>
+        <p:txBody>
+          <a:bodyPr wrap="square" lIns="0" tIns="0" rIns="0" bIns="0" rtlCol="0" anchor="ctr"/>
+          <a:lstStyle/>
+          <a:p>
+            <a:pPr indent="0" marL="0">
+              <a:buNone/>
+            </a:pPr>
+            <a:r>
+              <a:rPr lang="en-US" sz="950" b="1" spc="300" kern="0" dirty="0">
+                <a:solidFill>
+                  <a:srgbClr val="6B6A64"/>
+                </a:solidFill>
+                <a:latin typeface="Calibri" pitchFamily="34" charset="0"/>
+                <a:ea typeface="Calibri" pitchFamily="34" charset="-122"/>
+                <a:cs typeface="Calibri" pitchFamily="34" charset="-120"/>
+              </a:rPr>
+              <a:t>RIALTO · NINE DAYS · ONE PERSON</a:t>
+            </a:r>
+            <a:endParaRPr lang="en-US" sz="950" dirty="0"/>
+          </a:p>
+        </p:txBody>
+      </p:sp>
+      <p:sp>
+        <p:nvSpPr>
+          <p:cNvPr id="17" name="Text 15"/>
+          <p:cNvSpPr txBox="1"/>
+          <p:nvPr/>
+        </p:nvSpPr>
+        <p:spPr>
+          <a:xfrm>
+            <a:off x="5577840" y="2148840"/>
+            <a:ext cx="1463040" cy="365760"/>
+          </a:xfrm>
+          <a:prstGeom prst="rect">
+            <a:avLst/>
+          </a:prstGeom>
+          <a:noFill/>
+          <a:ln/>
+        </p:spPr>
+        <p:txBody>
+          <a:bodyPr wrap="square" lIns="0" tIns="0" rIns="0" bIns="0" rtlCol="0" anchor="ctr"/>
+          <a:lstStyle/>
+          <a:p>
+            <a:pPr indent="0" marL="0">
+              <a:buNone/>
+            </a:pPr>
+            <a:r>
+              <a:rPr lang="en-US" sz="2000" b="1" dirty="0">
                 <a:solidFill>
                   <a:srgbClr val="FFFFFF"/>
                 </a:solidFill>
@@ -4307,22 +4814,22 @@
                 <a:ea typeface="Arial" pitchFamily="34" charset="-122"/>
                 <a:cs typeface="Arial" pitchFamily="34" charset="-120"/>
               </a:rPr>
-              <a:t>Germline</a:t>
-            </a:r>
-            <a:endParaRPr lang="en-US" sz="1700" dirty="0"/>
-          </a:p>
-        </p:txBody>
-      </p:sp>
-      <p:sp>
-        <p:nvSpPr>
-          <p:cNvPr id="5" name="Text 3"/>
-          <p:cNvSpPr txBox="1"/>
-          <p:nvPr/>
-        </p:nvSpPr>
-        <p:spPr>
-          <a:xfrm>
-            <a:off x="640080" y="3172968"/>
-            <a:ext cx="3840480" cy="502920"/>
+              <a:t>6</a:t>
+            </a:r>
+            <a:endParaRPr lang="en-US" sz="2000" dirty="0"/>
+          </a:p>
+        </p:txBody>
+      </p:sp>
+      <p:sp>
+        <p:nvSpPr>
+          <p:cNvPr id="18" name="Text 16"/>
+          <p:cNvSpPr txBox="1"/>
+          <p:nvPr/>
+        </p:nvSpPr>
+        <p:spPr>
+          <a:xfrm>
+            <a:off x="5577840" y="2514600"/>
+            <a:ext cx="1463040" cy="365760"/>
           </a:xfrm>
           <a:prstGeom prst="rect">
             <a:avLst/>
@@ -4338,7 +4845,7 @@
               <a:buNone/>
             </a:pPr>
             <a:r>
-              <a:rPr lang="en-US" sz="1050" dirty="0">
+              <a:rPr lang="en-US" sz="850" dirty="0">
                 <a:solidFill>
                   <a:srgbClr val="8D8B82"/>
                 </a:solidFill>
@@ -4346,22 +4853,22 @@
                 <a:ea typeface="Calibri" pitchFamily="34" charset="-122"/>
                 <a:cs typeface="Calibri" pitchFamily="34" charset="-120"/>
               </a:rPr>
-              <a:t>Verifiable AI-configuration tuning, live on 0G mainnet — every step recorded on-chain.</a:t>
-            </a:r>
-            <a:endParaRPr lang="en-US" sz="1050" dirty="0"/>
-          </a:p>
-        </p:txBody>
-      </p:sp>
-      <p:sp>
-        <p:nvSpPr>
-          <p:cNvPr id="6" name="Text 4"/>
-          <p:cNvSpPr txBox="1"/>
-          <p:nvPr/>
-        </p:nvSpPr>
-        <p:spPr>
-          <a:xfrm>
-            <a:off x="4709160" y="2788920"/>
-            <a:ext cx="3840480" cy="384048"/>
+              <a:t>contracts, source-verified on Arc</a:t>
+            </a:r>
+            <a:endParaRPr lang="en-US" sz="850" dirty="0"/>
+          </a:p>
+        </p:txBody>
+      </p:sp>
+      <p:sp>
+        <p:nvSpPr>
+          <p:cNvPr id="19" name="Text 17"/>
+          <p:cNvSpPr txBox="1"/>
+          <p:nvPr/>
+        </p:nvSpPr>
+        <p:spPr>
+          <a:xfrm>
+            <a:off x="7086600" y="2148840"/>
+            <a:ext cx="1463040" cy="365760"/>
           </a:xfrm>
           <a:prstGeom prst="rect">
             <a:avLst/>
@@ -4377,7 +4884,7 @@
               <a:buNone/>
             </a:pPr>
             <a:r>
-              <a:rPr lang="en-US" sz="1700" b="1" dirty="0">
+              <a:rPr lang="en-US" sz="2000" b="1" dirty="0">
                 <a:solidFill>
                   <a:srgbClr val="FFFFFF"/>
                 </a:solidFill>
@@ -4385,22 +4892,22 @@
                 <a:ea typeface="Arial" pitchFamily="34" charset="-122"/>
                 <a:cs typeface="Arial" pitchFamily="34" charset="-120"/>
               </a:rPr>
-              <a:t>BIP 360 conformance</a:t>
-            </a:r>
-            <a:endParaRPr lang="en-US" sz="1700" dirty="0"/>
-          </a:p>
-        </p:txBody>
-      </p:sp>
-      <p:sp>
-        <p:nvSpPr>
-          <p:cNvPr id="7" name="Text 5"/>
-          <p:cNvSpPr txBox="1"/>
-          <p:nvPr/>
-        </p:nvSpPr>
-        <p:spPr>
-          <a:xfrm>
-            <a:off x="4709160" y="3172968"/>
-            <a:ext cx="3840480" cy="502920"/>
+              <a:t>71</a:t>
+            </a:r>
+            <a:endParaRPr lang="en-US" sz="2000" dirty="0"/>
+          </a:p>
+        </p:txBody>
+      </p:sp>
+      <p:sp>
+        <p:nvSpPr>
+          <p:cNvPr id="20" name="Text 18"/>
+          <p:cNvSpPr txBox="1"/>
+          <p:nvPr/>
+        </p:nvSpPr>
+        <p:spPr>
+          <a:xfrm>
+            <a:off x="7086600" y="2514600"/>
+            <a:ext cx="1463040" cy="365760"/>
           </a:xfrm>
           <a:prstGeom prst="rect">
             <a:avLst/>
@@ -4416,7 +4923,7 @@
               <a:buNone/>
             </a:pPr>
             <a:r>
-              <a:rPr lang="en-US" sz="1050" dirty="0">
+              <a:rPr lang="en-US" sz="850" dirty="0">
                 <a:solidFill>
                   <a:srgbClr val="8D8B82"/>
                 </a:solidFill>
@@ -4424,22 +4931,22 @@
                 <a:ea typeface="Calibri" pitchFamily="34" charset="-122"/>
                 <a:cs typeface="Calibri" pitchFamily="34" charset="-120"/>
               </a:rPr>
-              <a:t>From-scratch implementation vs the official reference: 13 vectors, 2,000 random trees, two real gaps found in the reference.</a:t>
-            </a:r>
-            <a:endParaRPr lang="en-US" sz="1050" dirty="0"/>
-          </a:p>
-        </p:txBody>
-      </p:sp>
-      <p:sp>
-        <p:nvSpPr>
-          <p:cNvPr id="8" name="Text 6"/>
-          <p:cNvSpPr txBox="1"/>
-          <p:nvPr/>
-        </p:nvSpPr>
-        <p:spPr>
-          <a:xfrm>
-            <a:off x="640080" y="3703320"/>
-            <a:ext cx="3840480" cy="384048"/>
+              <a:t>passing tests</a:t>
+            </a:r>
+            <a:endParaRPr lang="en-US" sz="850" dirty="0"/>
+          </a:p>
+        </p:txBody>
+      </p:sp>
+      <p:sp>
+        <p:nvSpPr>
+          <p:cNvPr id="21" name="Text 19"/>
+          <p:cNvSpPr txBox="1"/>
+          <p:nvPr/>
+        </p:nvSpPr>
+        <p:spPr>
+          <a:xfrm>
+            <a:off x="5577840" y="2898648"/>
+            <a:ext cx="1463040" cy="365760"/>
           </a:xfrm>
           <a:prstGeom prst="rect">
             <a:avLst/>
@@ -4455,7 +4962,7 @@
               <a:buNone/>
             </a:pPr>
             <a:r>
-              <a:rPr lang="en-US" sz="1700" b="1" dirty="0">
+              <a:rPr lang="en-US" sz="2000" b="1" dirty="0">
                 <a:solidFill>
                   <a:srgbClr val="FFFFFF"/>
                 </a:solidFill>
@@ -4463,22 +4970,22 @@
                 <a:ea typeface="Arial" pitchFamily="34" charset="-122"/>
                 <a:cs typeface="Arial" pitchFamily="34" charset="-120"/>
               </a:rPr>
-              <a:t>USDC/CCTP · Circle Wallets</a:t>
-            </a:r>
-            <a:endParaRPr lang="en-US" sz="1700" dirty="0"/>
-          </a:p>
-        </p:txBody>
-      </p:sp>
-      <p:sp>
-        <p:nvSpPr>
-          <p:cNvPr id="9" name="Text 7"/>
-          <p:cNvSpPr txBox="1"/>
-          <p:nvPr/>
-        </p:nvSpPr>
-        <p:spPr>
-          <a:xfrm>
-            <a:off x="640080" y="4087368"/>
-            <a:ext cx="3840480" cy="502920"/>
+              <a:t>259</a:t>
+            </a:r>
+            <a:endParaRPr lang="en-US" sz="2000" dirty="0"/>
+          </a:p>
+        </p:txBody>
+      </p:sp>
+      <p:sp>
+        <p:nvSpPr>
+          <p:cNvPr id="22" name="Text 20"/>
+          <p:cNvSpPr txBox="1"/>
+          <p:nvPr/>
+        </p:nvSpPr>
+        <p:spPr>
+          <a:xfrm>
+            <a:off x="5577840" y="3264408"/>
+            <a:ext cx="1463040" cy="365760"/>
           </a:xfrm>
           <a:prstGeom prst="rect">
             <a:avLst/>
@@ -4494,7 +5001,7 @@
               <a:buNone/>
             </a:pPr>
             <a:r>
-              <a:rPr lang="en-US" sz="1050" dirty="0">
+              <a:rPr lang="en-US" sz="850" dirty="0">
                 <a:solidFill>
                   <a:srgbClr val="8D8B82"/>
                 </a:solidFill>
@@ -4502,22 +5009,22 @@
                 <a:ea typeface="Calibri" pitchFamily="34" charset="-122"/>
                 <a:cs typeface="Calibri" pitchFamily="34" charset="-120"/>
               </a:rPr>
-              <a:t>Already shipped: proofflow (USDC, CCTP, Arcium MPC, live) and an agent on Circle Developer Controlled Wallets.</a:t>
-            </a:r>
-            <a:endParaRPr lang="en-US" sz="1050" dirty="0"/>
-          </a:p>
-        </p:txBody>
-      </p:sp>
-      <p:sp>
-        <p:nvSpPr>
-          <p:cNvPr id="10" name="Text 8"/>
-          <p:cNvSpPr txBox="1"/>
-          <p:nvPr/>
-        </p:nvSpPr>
-        <p:spPr>
-          <a:xfrm>
-            <a:off x="4709160" y="3703320"/>
-            <a:ext cx="3840480" cy="384048"/>
+              <a:t>days of ECB data, six corridors</a:t>
+            </a:r>
+            <a:endParaRPr lang="en-US" sz="850" dirty="0"/>
+          </a:p>
+        </p:txBody>
+      </p:sp>
+      <p:sp>
+        <p:nvSpPr>
+          <p:cNvPr id="23" name="Text 21"/>
+          <p:cNvSpPr txBox="1"/>
+          <p:nvPr/>
+        </p:nvSpPr>
+        <p:spPr>
+          <a:xfrm>
+            <a:off x="7086600" y="2898648"/>
+            <a:ext cx="1463040" cy="365760"/>
           </a:xfrm>
           <a:prstGeom prst="rect">
             <a:avLst/>
@@ -4533,30 +5040,30 @@
               <a:buNone/>
             </a:pPr>
             <a:r>
-              <a:rPr lang="en-US" sz="1700" b="1" dirty="0">
-                <a:solidFill>
-                  <a:srgbClr val="FFFFFF"/>
+              <a:rPr lang="en-US" sz="2000" b="1" dirty="0">
+                <a:solidFill>
+                  <a:srgbClr val="1BAF7A"/>
                 </a:solidFill>
                 <a:latin typeface="Arial" pitchFamily="34" charset="0"/>
                 <a:ea typeface="Arial" pitchFamily="34" charset="-122"/>
                 <a:cs typeface="Arial" pitchFamily="34" charset="-120"/>
               </a:rPr>
-              <a:t>Rialto, nine days</a:t>
-            </a:r>
-            <a:endParaRPr lang="en-US" sz="1700" dirty="0"/>
-          </a:p>
-        </p:txBody>
-      </p:sp>
-      <p:sp>
-        <p:nvSpPr>
-          <p:cNvPr id="11" name="Text 9"/>
-          <p:cNvSpPr txBox="1"/>
-          <p:nvPr/>
-        </p:nvSpPr>
-        <p:spPr>
-          <a:xfrm>
-            <a:off x="4709160" y="4087368"/>
-            <a:ext cx="3840480" cy="502920"/>
+              <a:t>37.8→3.2%</a:t>
+            </a:r>
+            <a:endParaRPr lang="en-US" sz="2000" dirty="0"/>
+          </a:p>
+        </p:txBody>
+      </p:sp>
+      <p:sp>
+        <p:nvSpPr>
+          <p:cNvPr id="24" name="Text 22"/>
+          <p:cNvSpPr txBox="1"/>
+          <p:nvPr/>
+        </p:nvSpPr>
+        <p:spPr>
+          <a:xfrm>
+            <a:off x="7086600" y="3264408"/>
+            <a:ext cx="1463040" cy="365760"/>
           </a:xfrm>
           <a:prstGeom prst="rect">
             <a:avLst/>
@@ -4572,7 +5079,7 @@
               <a:buNone/>
             </a:pPr>
             <a:r>
-              <a:rPr lang="en-US" sz="1050" dirty="0">
+              <a:rPr lang="en-US" sz="850" dirty="0">
                 <a:solidFill>
                   <a:srgbClr val="8D8B82"/>
                 </a:solidFill>
@@ -4580,22 +5087,22 @@
                 <a:ea typeface="Calibri" pitchFamily="34" charset="-122"/>
                 <a:cs typeface="Calibri" pitchFamily="34" charset="-120"/>
               </a:rPr>
-              <a:t>Six verified contracts, 71 tests, a 259-day backtest, an adversarial review, a settled invoice and forward, a demo video.</a:t>
-            </a:r>
-            <a:endParaRPr lang="en-US" sz="1050" dirty="0"/>
-          </a:p>
-        </p:txBody>
-      </p:sp>
-      <p:sp>
-        <p:nvSpPr>
-          <p:cNvPr id="12" name="Text 10"/>
-          <p:cNvSpPr txBox="1"/>
-          <p:nvPr/>
-        </p:nvSpPr>
-        <p:spPr>
-          <a:xfrm>
-            <a:off x="640080" y="4572000"/>
-            <a:ext cx="7863840" cy="320040"/>
+              <a:t>oracle failure mode, found and bounded</a:t>
+            </a:r>
+            <a:endParaRPr lang="en-US" sz="850" dirty="0"/>
+          </a:p>
+        </p:txBody>
+      </p:sp>
+      <p:sp>
+        <p:nvSpPr>
+          <p:cNvPr id="25" name="Text 23"/>
+          <p:cNvSpPr txBox="1"/>
+          <p:nvPr/>
+        </p:nvSpPr>
+        <p:spPr>
+          <a:xfrm>
+            <a:off x="5577840" y="3648456"/>
+            <a:ext cx="1463040" cy="365760"/>
           </a:xfrm>
           <a:prstGeom prst="rect">
             <a:avLst/>
@@ -4611,7 +5118,163 @@
               <a:buNone/>
             </a:pPr>
             <a:r>
-              <a:rPr lang="en-US" sz="1050" dirty="0">
+              <a:rPr lang="en-US" sz="2000" b="1" dirty="0">
+                <a:solidFill>
+                  <a:srgbClr val="1BAF7A"/>
+                </a:solidFill>
+                <a:latin typeface="Arial" pitchFamily="34" charset="0"/>
+                <a:ea typeface="Arial" pitchFamily="34" charset="-122"/>
+                <a:cs typeface="Arial" pitchFamily="34" charset="-120"/>
+              </a:rPr>
+              <a:t>1 + 1</a:t>
+            </a:r>
+            <a:endParaRPr lang="en-US" sz="2000" dirty="0"/>
+          </a:p>
+        </p:txBody>
+      </p:sp>
+      <p:sp>
+        <p:nvSpPr>
+          <p:cNvPr id="26" name="Text 24"/>
+          <p:cNvSpPr txBox="1"/>
+          <p:nvPr/>
+        </p:nvSpPr>
+        <p:spPr>
+          <a:xfrm>
+            <a:off x="5577840" y="4014216"/>
+            <a:ext cx="1463040" cy="365760"/>
+          </a:xfrm>
+          <a:prstGeom prst="rect">
+            <a:avLst/>
+          </a:prstGeom>
+          <a:noFill/>
+          <a:ln/>
+        </p:spPr>
+        <p:txBody>
+          <a:bodyPr wrap="square" lIns="0" tIns="0" rIns="0" bIns="0" rtlCol="0" anchor="t"/>
+          <a:lstStyle/>
+          <a:p>
+            <a:pPr indent="0" marL="0">
+              <a:buNone/>
+            </a:pPr>
+            <a:r>
+              <a:rPr lang="en-US" sz="850" dirty="0">
+                <a:solidFill>
+                  <a:srgbClr val="8D8B82"/>
+                </a:solidFill>
+                <a:latin typeface="Calibri" pitchFamily="34" charset="0"/>
+                <a:ea typeface="Calibri" pitchFamily="34" charset="-122"/>
+                <a:cs typeface="Calibri" pitchFamily="34" charset="-120"/>
+              </a:rPr>
+              <a:t>invoice and forward, settled on-chain</a:t>
+            </a:r>
+            <a:endParaRPr lang="en-US" sz="850" dirty="0"/>
+          </a:p>
+        </p:txBody>
+      </p:sp>
+      <p:sp>
+        <p:nvSpPr>
+          <p:cNvPr id="27" name="Text 25"/>
+          <p:cNvSpPr txBox="1"/>
+          <p:nvPr/>
+        </p:nvSpPr>
+        <p:spPr>
+          <a:xfrm>
+            <a:off x="7086600" y="3648456"/>
+            <a:ext cx="1463040" cy="365760"/>
+          </a:xfrm>
+          <a:prstGeom prst="rect">
+            <a:avLst/>
+          </a:prstGeom>
+          <a:noFill/>
+          <a:ln/>
+        </p:spPr>
+        <p:txBody>
+          <a:bodyPr wrap="square" lIns="0" tIns="0" rIns="0" bIns="0" rtlCol="0" anchor="ctr"/>
+          <a:lstStyle/>
+          <a:p>
+            <a:pPr indent="0" marL="0">
+              <a:buNone/>
+            </a:pPr>
+            <a:r>
+              <a:rPr lang="en-US" sz="2000" b="1" dirty="0">
+                <a:solidFill>
+                  <a:srgbClr val="FFFFFF"/>
+                </a:solidFill>
+                <a:latin typeface="Arial" pitchFamily="34" charset="0"/>
+                <a:ea typeface="Arial" pitchFamily="34" charset="-122"/>
+                <a:cs typeface="Arial" pitchFamily="34" charset="-120"/>
+              </a:rPr>
+              <a:t>4:34</a:t>
+            </a:r>
+            <a:endParaRPr lang="en-US" sz="2000" dirty="0"/>
+          </a:p>
+        </p:txBody>
+      </p:sp>
+      <p:sp>
+        <p:nvSpPr>
+          <p:cNvPr id="28" name="Text 26"/>
+          <p:cNvSpPr txBox="1"/>
+          <p:nvPr/>
+        </p:nvSpPr>
+        <p:spPr>
+          <a:xfrm>
+            <a:off x="7086600" y="4014216"/>
+            <a:ext cx="1463040" cy="365760"/>
+          </a:xfrm>
+          <a:prstGeom prst="rect">
+            <a:avLst/>
+          </a:prstGeom>
+          <a:noFill/>
+          <a:ln/>
+        </p:spPr>
+        <p:txBody>
+          <a:bodyPr wrap="square" lIns="0" tIns="0" rIns="0" bIns="0" rtlCol="0" anchor="t"/>
+          <a:lstStyle/>
+          <a:p>
+            <a:pPr indent="0" marL="0">
+              <a:buNone/>
+            </a:pPr>
+            <a:r>
+              <a:rPr lang="en-US" sz="850" dirty="0">
+                <a:solidFill>
+                  <a:srgbClr val="8D8B82"/>
+                </a:solidFill>
+                <a:latin typeface="Calibri" pitchFamily="34" charset="0"/>
+                <a:ea typeface="Calibri" pitchFamily="34" charset="-122"/>
+                <a:cs typeface="Calibri" pitchFamily="34" charset="-120"/>
+              </a:rPr>
+              <a:t>demo video, reproducible from the repo</a:t>
+            </a:r>
+            <a:endParaRPr lang="en-US" sz="850" dirty="0"/>
+          </a:p>
+        </p:txBody>
+      </p:sp>
+      <p:sp>
+        <p:nvSpPr>
+          <p:cNvPr id="29" name="Text 27"/>
+          <p:cNvSpPr txBox="1"/>
+          <p:nvPr/>
+        </p:nvSpPr>
+        <p:spPr>
+          <a:xfrm>
+            <a:off x="640080" y="4709160"/>
+            <a:ext cx="7863840" cy="274320"/>
+          </a:xfrm>
+          <a:prstGeom prst="rect">
+            <a:avLst/>
+          </a:prstGeom>
+          <a:noFill/>
+          <a:ln/>
+        </p:spPr>
+        <p:txBody>
+          <a:bodyPr wrap="square" lIns="0" tIns="0" rIns="0" bIns="0" rtlCol="0" anchor="ctr"/>
+          <a:lstStyle/>
+          <a:p>
+            <a:pPr indent="0" marL="0">
+              <a:buNone/>
+            </a:pPr>
+            <a:r>
+              <a:rPr lang="en-US" sz="1000" dirty="0">
                 <a:solidFill>
                   <a:srgbClr val="8D8B82"/>
                 </a:solidFill>
@@ -4621,7 +5284,7 @@
               </a:rPr>
               <a:t>github.com/let-the-dreamers-rise · 123 repositories · 901 contributions in the last year · rialto-arc.netlify.app</a:t>
             </a:r>
-            <a:endParaRPr lang="en-US" sz="1050" dirty="0"/>
+            <a:endParaRPr lang="en-US" sz="1000" dirty="0"/>
           </a:p>
         </p:txBody>
       </p:sp>

</xml_diff>